<commit_message>
feat: update token limits to 1.5M/5M across all files + pricing deck
</commit_message>
<xml_diff>
--- a/ApplyPilot_Pricing.pptx
+++ b/ApplyPilot_Pricing.pptx
@@ -1303,7 +1303,7 @@
                 <a:ea typeface="Calibri" pitchFamily="34" charset="-122"/>
                 <a:cs typeface="Calibri" pitchFamily="34" charset="-120"/>
               </a:rPr>
-              <a:t>10 </a:t>
+              <a:t xml:space="preserve">10 </a:t>
             </a:r>
             <a:r>
               <a:rPr lang="en-US" sz="950" dirty="0">
@@ -1385,7 +1385,7 @@
                 <a:ea typeface="Calibri" pitchFamily="34" charset="-122"/>
                 <a:cs typeface="Calibri" pitchFamily="34" charset="-120"/>
               </a:rPr>
-              <a:t>750k AI Tokens / mo</a:t>
+              <a:t>1.5M AI Tokens / mo</a:t>
             </a:r>
             <a:endParaRPr lang="en-US" sz="950" dirty="0"/>
           </a:p>
@@ -2111,7 +2111,7 @@
                 <a:ea typeface="Calibri" pitchFamily="34" charset="-122"/>
                 <a:cs typeface="Calibri" pitchFamily="34" charset="-120"/>
               </a:rPr>
-              <a:t>2.5M AI Tokens / mo</a:t>
+              <a:t>5M AI Tokens / mo</a:t>
             </a:r>
             <a:endParaRPr lang="en-US" sz="950" dirty="0"/>
           </a:p>
@@ -3525,7 +3525,7 @@
                 <a:ea typeface="Calibri" pitchFamily="34" charset="-122"/>
                 <a:cs typeface="Calibri" pitchFamily="34" charset="-120"/>
               </a:rPr>
-              <a:t>+2  </a:t>
+              <a:t xml:space="preserve">+2  </a:t>
             </a:r>
             <a:r>
               <a:rPr lang="en-US" sz="1050" dirty="0">
@@ -3607,7 +3607,7 @@
                 <a:ea typeface="Calibri" pitchFamily="34" charset="-122"/>
                 <a:cs typeface="Calibri" pitchFamily="34" charset="-120"/>
               </a:rPr>
-              <a:t>+10  </a:t>
+              <a:t xml:space="preserve">+10  </a:t>
             </a:r>
             <a:r>
               <a:rPr lang="en-US" sz="1050" dirty="0">
@@ -3989,7 +3989,7 @@
                 <a:ea typeface="Calibri" pitchFamily="34" charset="-122"/>
                 <a:cs typeface="Calibri" pitchFamily="34" charset="-120"/>
               </a:rPr>
-              <a:t>+4  </a:t>
+              <a:t xml:space="preserve">+4  </a:t>
             </a:r>
             <a:r>
               <a:rPr lang="en-US" sz="1050" dirty="0">
@@ -4071,7 +4071,7 @@
                 <a:ea typeface="Calibri" pitchFamily="34" charset="-122"/>
                 <a:cs typeface="Calibri" pitchFamily="34" charset="-120"/>
               </a:rPr>
-              <a:t>+20  </a:t>
+              <a:t xml:space="preserve">+20  </a:t>
             </a:r>
             <a:r>
               <a:rPr lang="en-US" sz="1050" dirty="0">
@@ -4453,7 +4453,7 @@
                 <a:ea typeface="Calibri" pitchFamily="34" charset="-122"/>
                 <a:cs typeface="Calibri" pitchFamily="34" charset="-120"/>
               </a:rPr>
-              <a:t>+6  </a:t>
+              <a:t xml:space="preserve">+6  </a:t>
             </a:r>
             <a:r>
               <a:rPr lang="en-US" sz="1050" dirty="0">
@@ -4535,7 +4535,7 @@
                 <a:ea typeface="Calibri" pitchFamily="34" charset="-122"/>
                 <a:cs typeface="Calibri" pitchFamily="34" charset="-120"/>
               </a:rPr>
-              <a:t>+35  </a:t>
+              <a:t xml:space="preserve">+35  </a:t>
             </a:r>
             <a:r>
               <a:rPr lang="en-US" sz="1050" dirty="0">
@@ -4948,7 +4948,7 @@
                 <a:ea typeface="Calibri" pitchFamily="34" charset="-122"/>
                 <a:cs typeface="Calibri" pitchFamily="34" charset="-120"/>
               </a:rPr>
-              <a:t>+250k</a:t>
+              <a:t>+500k</a:t>
             </a:r>
             <a:endParaRPr lang="en-US" sz="3000" dirty="0"/>
           </a:p>
@@ -5067,7 +5067,7 @@
                 <a:ea typeface="Calibri" pitchFamily="34" charset="-122"/>
                 <a:cs typeface="Calibri" pitchFamily="34" charset="-120"/>
               </a:rPr>
-              <a:t> /mo</a:t>
+              <a:t xml:space="preserve"> /mo</a:t>
             </a:r>
             <a:endParaRPr lang="en-US" sz="2600" dirty="0"/>
           </a:p>
@@ -5255,7 +5255,7 @@
                 <a:ea typeface="Calibri" pitchFamily="34" charset="-122"/>
                 <a:cs typeface="Calibri" pitchFamily="34" charset="-120"/>
               </a:rPr>
-              <a:t>+1M</a:t>
+              <a:t>+2M</a:t>
             </a:r>
             <a:endParaRPr lang="en-US" sz="3000" dirty="0"/>
           </a:p>
@@ -5374,7 +5374,7 @@
                 <a:ea typeface="Calibri" pitchFamily="34" charset="-122"/>
                 <a:cs typeface="Calibri" pitchFamily="34" charset="-120"/>
               </a:rPr>
-              <a:t> /mo</a:t>
+              <a:t xml:space="preserve"> /mo</a:t>
             </a:r>
             <a:endParaRPr lang="en-US" sz="2600" dirty="0"/>
           </a:p>
@@ -5562,7 +5562,7 @@
                 <a:ea typeface="Calibri" pitchFamily="34" charset="-122"/>
                 <a:cs typeface="Calibri" pitchFamily="34" charset="-120"/>
               </a:rPr>
-              <a:t>+5M</a:t>
+              <a:t>+10M</a:t>
             </a:r>
             <a:endParaRPr lang="en-US" sz="3000" dirty="0"/>
           </a:p>
@@ -5681,7 +5681,7 @@
                 <a:ea typeface="Calibri" pitchFamily="34" charset="-122"/>
                 <a:cs typeface="Calibri" pitchFamily="34" charset="-120"/>
               </a:rPr>
-              <a:t> /mo</a:t>
+              <a:t xml:space="preserve"> /mo</a:t>
             </a:r>
             <a:endParaRPr lang="en-US" sz="2600" dirty="0"/>
           </a:p>
@@ -5869,7 +5869,7 @@
                 <a:ea typeface="Calibri" pitchFamily="34" charset="-122"/>
                 <a:cs typeface="Calibri" pitchFamily="34" charset="-120"/>
               </a:rPr>
-              <a:t>+15M</a:t>
+              <a:t>+30M</a:t>
             </a:r>
             <a:endParaRPr lang="en-US" sz="3000" dirty="0"/>
           </a:p>
@@ -5988,7 +5988,7 @@
                 <a:ea typeface="Calibri" pitchFamily="34" charset="-122"/>
                 <a:cs typeface="Calibri" pitchFamily="34" charset="-120"/>
               </a:rPr>
-              <a:t> /mo</a:t>
+              <a:t xml:space="preserve"> /mo</a:t>
             </a:r>
             <a:endParaRPr lang="en-US" sz="2600" dirty="0"/>
           </a:p>

</xml_diff>